<commit_message>
Update Hash Encoding presentation file
</commit_message>
<xml_diff>
--- a/My Note and Practice/Text to Numerical Data Conversion/Categorical(Text to Numeric) data conversion-CTtN/Nominal Data/CTNtN3. Hash Encoding/Hash Encoding.pptx
+++ b/My Note and Practice/Text to Numerical Data Conversion/Categorical(Text to Numeric) data conversion-CTtN/Nominal Data/CTNtN3. Hash Encoding/Hash Encoding.pptx
@@ -5,14 +5,15 @@
     <p:sldMasterId id="2147483648" r:id="rId1"/>
   </p:sldMasterIdLst>
   <p:sldIdLst>
-    <p:sldId id="322" r:id="rId2"/>
-    <p:sldId id="326" r:id="rId3"/>
-    <p:sldId id="335" r:id="rId4"/>
-    <p:sldId id="323" r:id="rId5"/>
-    <p:sldId id="324" r:id="rId6"/>
-    <p:sldId id="325" r:id="rId7"/>
-    <p:sldId id="329" r:id="rId8"/>
-    <p:sldId id="328" r:id="rId9"/>
+    <p:sldId id="336" r:id="rId2"/>
+    <p:sldId id="322" r:id="rId3"/>
+    <p:sldId id="326" r:id="rId4"/>
+    <p:sldId id="335" r:id="rId5"/>
+    <p:sldId id="323" r:id="rId6"/>
+    <p:sldId id="324" r:id="rId7"/>
+    <p:sldId id="325" r:id="rId8"/>
+    <p:sldId id="329" r:id="rId9"/>
+    <p:sldId id="328" r:id="rId10"/>
   </p:sldIdLst>
   <p:sldSz cx="12192000" cy="6858000"/>
   <p:notesSz cx="6858000" cy="9144000"/>
@@ -4863,7 +4864,7 @@
           <a:p>
             <a:fld id="{3493752B-1F48-49E5-A31F-3906341B6897}" type="datetimeFigureOut">
               <a:rPr lang="en-US" smtClean="0"/>
-              <a:t>11/17/2025</a:t>
+              <a:t>11/19/2025</a:t>
             </a:fld>
             <a:endParaRPr lang="en-US"/>
           </a:p>
@@ -5061,7 +5062,7 @@
           <a:p>
             <a:fld id="{3493752B-1F48-49E5-A31F-3906341B6897}" type="datetimeFigureOut">
               <a:rPr lang="en-US" smtClean="0"/>
-              <a:t>11/17/2025</a:t>
+              <a:t>11/19/2025</a:t>
             </a:fld>
             <a:endParaRPr lang="en-US"/>
           </a:p>
@@ -5269,7 +5270,7 @@
           <a:p>
             <a:fld id="{3493752B-1F48-49E5-A31F-3906341B6897}" type="datetimeFigureOut">
               <a:rPr lang="en-US" smtClean="0"/>
-              <a:t>11/17/2025</a:t>
+              <a:t>11/19/2025</a:t>
             </a:fld>
             <a:endParaRPr lang="en-US"/>
           </a:p>
@@ -5467,7 +5468,7 @@
           <a:p>
             <a:fld id="{3493752B-1F48-49E5-A31F-3906341B6897}" type="datetimeFigureOut">
               <a:rPr lang="en-US" smtClean="0"/>
-              <a:t>11/17/2025</a:t>
+              <a:t>11/19/2025</a:t>
             </a:fld>
             <a:endParaRPr lang="en-US"/>
           </a:p>
@@ -5742,7 +5743,7 @@
           <a:p>
             <a:fld id="{3493752B-1F48-49E5-A31F-3906341B6897}" type="datetimeFigureOut">
               <a:rPr lang="en-US" smtClean="0"/>
-              <a:t>11/17/2025</a:t>
+              <a:t>11/19/2025</a:t>
             </a:fld>
             <a:endParaRPr lang="en-US"/>
           </a:p>
@@ -6007,7 +6008,7 @@
           <a:p>
             <a:fld id="{3493752B-1F48-49E5-A31F-3906341B6897}" type="datetimeFigureOut">
               <a:rPr lang="en-US" smtClean="0"/>
-              <a:t>11/17/2025</a:t>
+              <a:t>11/19/2025</a:t>
             </a:fld>
             <a:endParaRPr lang="en-US"/>
           </a:p>
@@ -6419,7 +6420,7 @@
           <a:p>
             <a:fld id="{3493752B-1F48-49E5-A31F-3906341B6897}" type="datetimeFigureOut">
               <a:rPr lang="en-US" smtClean="0"/>
-              <a:t>11/17/2025</a:t>
+              <a:t>11/19/2025</a:t>
             </a:fld>
             <a:endParaRPr lang="en-US"/>
           </a:p>
@@ -6560,7 +6561,7 @@
           <a:p>
             <a:fld id="{3493752B-1F48-49E5-A31F-3906341B6897}" type="datetimeFigureOut">
               <a:rPr lang="en-US" smtClean="0"/>
-              <a:t>11/17/2025</a:t>
+              <a:t>11/19/2025</a:t>
             </a:fld>
             <a:endParaRPr lang="en-US"/>
           </a:p>
@@ -6673,7 +6674,7 @@
           <a:p>
             <a:fld id="{3493752B-1F48-49E5-A31F-3906341B6897}" type="datetimeFigureOut">
               <a:rPr lang="en-US" smtClean="0"/>
-              <a:t>11/17/2025</a:t>
+              <a:t>11/19/2025</a:t>
             </a:fld>
             <a:endParaRPr lang="en-US"/>
           </a:p>
@@ -6984,7 +6985,7 @@
           <a:p>
             <a:fld id="{3493752B-1F48-49E5-A31F-3906341B6897}" type="datetimeFigureOut">
               <a:rPr lang="en-US" smtClean="0"/>
-              <a:t>11/17/2025</a:t>
+              <a:t>11/19/2025</a:t>
             </a:fld>
             <a:endParaRPr lang="en-US"/>
           </a:p>
@@ -7272,7 +7273,7 @@
           <a:p>
             <a:fld id="{3493752B-1F48-49E5-A31F-3906341B6897}" type="datetimeFigureOut">
               <a:rPr lang="en-US" smtClean="0"/>
-              <a:t>11/17/2025</a:t>
+              <a:t>11/19/2025</a:t>
             </a:fld>
             <a:endParaRPr lang="en-US"/>
           </a:p>
@@ -7513,7 +7514,7 @@
           <a:p>
             <a:fld id="{3493752B-1F48-49E5-A31F-3906341B6897}" type="datetimeFigureOut">
               <a:rPr lang="en-US" smtClean="0"/>
-              <a:t>11/17/2025</a:t>
+              <a:t>11/19/2025</a:t>
             </a:fld>
             <a:endParaRPr lang="en-US"/>
           </a:p>
@@ -7918,6 +7919,102 @@
   <p:cSld>
     <p:spTree>
       <p:nvGrpSpPr>
+        <p:cNvPr id="1" name=""/>
+        <p:cNvGrpSpPr/>
+        <p:nvPr/>
+      </p:nvGrpSpPr>
+      <p:grpSpPr>
+        <a:xfrm>
+          <a:off x="0" y="0"/>
+          <a:ext cx="0" cy="0"/>
+          <a:chOff x="0" y="0"/>
+          <a:chExt cx="0" cy="0"/>
+        </a:xfrm>
+      </p:grpSpPr>
+      <p:sp>
+        <p:nvSpPr>
+          <p:cNvPr id="2" name="Title 1">
+            <a:extLst>
+              <a:ext uri="{FF2B5EF4-FFF2-40B4-BE49-F238E27FC236}">
+                <a16:creationId xmlns:a16="http://schemas.microsoft.com/office/drawing/2014/main" id="{BB326A4A-E541-DD2F-17BD-57910CCC297D}"/>
+              </a:ext>
+            </a:extLst>
+          </p:cNvPr>
+          <p:cNvSpPr>
+            <a:spLocks noGrp="1"/>
+          </p:cNvSpPr>
+          <p:nvPr>
+            <p:ph type="ctrTitle"/>
+          </p:nvPr>
+        </p:nvSpPr>
+        <p:spPr/>
+        <p:txBody>
+          <a:bodyPr>
+            <a:normAutofit/>
+          </a:bodyPr>
+          <a:lstStyle/>
+          <a:p>
+            <a:r>
+              <a:rPr lang="en-US" sz="7000" dirty="0">
+                <a:latin typeface="Bebas Neue" panose="020B0606020202050201" pitchFamily="34" charset="0"/>
+              </a:rPr>
+              <a:t>Hash Encoding in Machine Learning</a:t>
+            </a:r>
+          </a:p>
+        </p:txBody>
+      </p:sp>
+      <p:sp>
+        <p:nvSpPr>
+          <p:cNvPr id="3" name="Subtitle 2">
+            <a:extLst>
+              <a:ext uri="{FF2B5EF4-FFF2-40B4-BE49-F238E27FC236}">
+                <a16:creationId xmlns:a16="http://schemas.microsoft.com/office/drawing/2014/main" id="{1968A420-B083-5737-FC61-EFED591EEFCD}"/>
+              </a:ext>
+            </a:extLst>
+          </p:cNvPr>
+          <p:cNvSpPr>
+            <a:spLocks noGrp="1"/>
+          </p:cNvSpPr>
+          <p:nvPr>
+            <p:ph type="subTitle" idx="1"/>
+          </p:nvPr>
+        </p:nvSpPr>
+        <p:spPr/>
+        <p:txBody>
+          <a:bodyPr>
+            <a:normAutofit/>
+          </a:bodyPr>
+          <a:lstStyle/>
+          <a:p>
+            <a:r>
+              <a:rPr lang="en-US" sz="3200" dirty="0">
+                <a:latin typeface="Open Sans" pitchFamily="2" charset="0"/>
+                <a:ea typeface="Open Sans" pitchFamily="2" charset="0"/>
+                <a:cs typeface="Open Sans" pitchFamily="2" charset="0"/>
+              </a:rPr>
+              <a:t>A Fast and Scalable Technique That Uses Hash Functions to Encode Categorical Data</a:t>
+            </a:r>
+          </a:p>
+        </p:txBody>
+      </p:sp>
+    </p:spTree>
+    <p:extLst>
+      <p:ext uri="{BB962C8B-B14F-4D97-AF65-F5344CB8AC3E}">
+        <p14:creationId xmlns:p14="http://schemas.microsoft.com/office/powerpoint/2010/main" val="2363910525"/>
+      </p:ext>
+    </p:extLst>
+  </p:cSld>
+  <p:clrMapOvr>
+    <a:masterClrMapping/>
+  </p:clrMapOvr>
+</p:sld>
+</file>
+
+<file path=ppt/slides/slide2.xml><?xml version="1.0" encoding="utf-8"?>
+<p:sld xmlns:a="http://schemas.openxmlformats.org/drawingml/2006/main" xmlns:r="http://schemas.openxmlformats.org/officeDocument/2006/relationships" xmlns:p="http://schemas.openxmlformats.org/presentationml/2006/main">
+  <p:cSld>
+    <p:spTree>
+      <p:nvGrpSpPr>
         <p:cNvPr id="1" name="">
           <a:extLst>
             <a:ext uri="{FF2B5EF4-FFF2-40B4-BE49-F238E27FC236}">
@@ -8154,7 +8251,7 @@
 </p:sld>
 </file>
 
-<file path=ppt/slides/slide2.xml><?xml version="1.0" encoding="utf-8"?>
+<file path=ppt/slides/slide3.xml><?xml version="1.0" encoding="utf-8"?>
 <p:sld xmlns:a="http://schemas.openxmlformats.org/drawingml/2006/main" xmlns:r="http://schemas.openxmlformats.org/officeDocument/2006/relationships" xmlns:p="http://schemas.openxmlformats.org/presentationml/2006/main">
   <p:cSld>
     <p:spTree>
@@ -9400,7 +9497,7 @@
 </p:sld>
 </file>
 
-<file path=ppt/slides/slide3.xml><?xml version="1.0" encoding="utf-8"?>
+<file path=ppt/slides/slide4.xml><?xml version="1.0" encoding="utf-8"?>
 <p:sld xmlns:a="http://schemas.openxmlformats.org/drawingml/2006/main" xmlns:r="http://schemas.openxmlformats.org/officeDocument/2006/relationships" xmlns:p="http://schemas.openxmlformats.org/presentationml/2006/main">
   <p:cSld>
     <p:spTree>
@@ -9669,7 +9766,7 @@
 </p:sld>
 </file>
 
-<file path=ppt/slides/slide4.xml><?xml version="1.0" encoding="utf-8"?>
+<file path=ppt/slides/slide5.xml><?xml version="1.0" encoding="utf-8"?>
 <p:sld xmlns:a="http://schemas.openxmlformats.org/drawingml/2006/main" xmlns:r="http://schemas.openxmlformats.org/officeDocument/2006/relationships" xmlns:p="http://schemas.openxmlformats.org/presentationml/2006/main">
   <p:cSld>
     <p:spTree>
@@ -9977,7 +10074,7 @@
 </p:sld>
 </file>
 
-<file path=ppt/slides/slide5.xml><?xml version="1.0" encoding="utf-8"?>
+<file path=ppt/slides/slide6.xml><?xml version="1.0" encoding="utf-8"?>
 <p:sld xmlns:a="http://schemas.openxmlformats.org/drawingml/2006/main" xmlns:r="http://schemas.openxmlformats.org/officeDocument/2006/relationships" xmlns:p="http://schemas.openxmlformats.org/presentationml/2006/main">
   <p:cSld>
     <p:spTree>
@@ -10383,7 +10480,7 @@
 </p:sld>
 </file>
 
-<file path=ppt/slides/slide6.xml><?xml version="1.0" encoding="utf-8"?>
+<file path=ppt/slides/slide7.xml><?xml version="1.0" encoding="utf-8"?>
 <p:sld xmlns:a="http://schemas.openxmlformats.org/drawingml/2006/main" xmlns:r="http://schemas.openxmlformats.org/officeDocument/2006/relationships" xmlns:p="http://schemas.openxmlformats.org/presentationml/2006/main">
   <p:cSld>
     <p:spTree>
@@ -10614,7 +10711,7 @@
 </p:sld>
 </file>
 
-<file path=ppt/slides/slide7.xml><?xml version="1.0" encoding="utf-8"?>
+<file path=ppt/slides/slide8.xml><?xml version="1.0" encoding="utf-8"?>
 <p:sld xmlns:a="http://schemas.openxmlformats.org/drawingml/2006/main" xmlns:r="http://schemas.openxmlformats.org/officeDocument/2006/relationships" xmlns:p="http://schemas.openxmlformats.org/presentationml/2006/main">
   <p:cSld>
     <p:spTree>
@@ -10893,7 +10990,7 @@
 </p:sld>
 </file>
 
-<file path=ppt/slides/slide8.xml><?xml version="1.0" encoding="utf-8"?>
+<file path=ppt/slides/slide9.xml><?xml version="1.0" encoding="utf-8"?>
 <p:sld xmlns:a="http://schemas.openxmlformats.org/drawingml/2006/main" xmlns:r="http://schemas.openxmlformats.org/officeDocument/2006/relationships" xmlns:p="http://schemas.openxmlformats.org/presentationml/2006/main">
   <p:cSld>
     <p:spTree>

</xml_diff>